<commit_message>
Mentor-unblocked: spec-vs-OEM-sheet check, cloned-paperwork case, test-data note
Mentors confirmed spec-on-paper is in scope: new spec_matches_oem_sheet validator (18 checks now) with an OEM spec-sheet stub keyed by part number. New case suspect_cloned_spec: a genuine supplier's identity borrowed wholesale, betrayed only by the wrong claimed standard - the direct answer to the cloned-paperwork attack. docs/test-data-note.md packages the 13 cases as the formal test-data submission (the jury's unseen scenario will be built from it). 83 tests; 13/13 mock; spec case verified live.

Co-Authored-By: Claude Fable 5 <noreply@anthropic.com>
</commit_message>
<xml_diff>
--- a/docs/provenance-deck.pptx
+++ b/docs/provenance-deck.pptx
@@ -4620,7 +4620,7 @@
                 <a:ea typeface="Calibri" pitchFamily="34" charset="-122"/>
                 <a:cs typeface="Calibri" pitchFamily="34" charset="-120"/>
               </a:rPr>
-              <a:t>17 deterministic checks against a real 3.67M-company MCA registry, offline</a:t>
+              <a:t>18 deterministic checks against a real 3.67M-company MCA registry, offline</a:t>
             </a:r>
             <a:endParaRPr lang="en-US" sz="1400" dirty="0"/>
           </a:p>
@@ -5799,7 +5799,7 @@
                 <a:ea typeface="Calibri" pitchFamily="34" charset="-122"/>
                 <a:cs typeface="Calibri" pitchFamily="34" charset="-120"/>
               </a:rPr>
-              <a:t>17 pure deterministic checks: checksums, date logic, registry cross-checks. Facts with one right answer never go to a model.</a:t>
+              <a:t>18 pure deterministic checks: checksums, date logic, registry cross-checks. Facts with one right answer never go to a model.</a:t>
             </a:r>
             <a:endParaRPr lang="en-US" sz="1150" dirty="0"/>
           </a:p>
@@ -9390,7 +9390,7 @@
                 <a:ea typeface="Calibri" pitchFamily="34" charset="-122"/>
                 <a:cs typeface="Calibri" pitchFamily="34" charset="-120"/>
               </a:rPr>
-              <a:t>Paste any documents as plain text — no format needed. The pipeline runs live: extraction, 17 checks, deliberation, verdict. We built for contradictions, not scenarios, so unseen input is the test we want.</a:t>
+              <a:t>Paste any documents as plain text — no format needed. The pipeline runs live: extraction, 18 checks, deliberation, verdict. We built for contradictions, not scenarios, so unseen input is the test we want.</a:t>
             </a:r>
             <a:endParaRPr lang="en-US" sz="1250" dirty="0"/>
           </a:p>

</xml_diff>